<commit_message>
Story slide: tighten left rail, fix tile 10 height + alignment
- Left rail: trim mission body box to fit text; punchline bottom-anchored
  so its base aligns with the bottom of right column tile 10
- Headline / persona / mission spacing tightened
- Tile 10 (Agent Builder): 0.58 in -> 0.78 in so the body description sits
  comfortably inside the rounded tile instead of hugging the bottom edge
- Panel height bumped to 5.95 in to accommodate the taller agent tile
- Value bar height trimmed to 0.28 in to keep it on slide

Co-authored-by: Copilot <223556219+Copilot@users.noreply.github.com>
</commit_message>
<xml_diff>
--- a/files/05_Rivanta_StorySlide.pptx
+++ b/files/05_Rivanta_StorySlide.pptx
@@ -3207,7 +3207,7 @@
         <p:spPr>
           <a:xfrm>
             <a:off x="457200" y="1097280"/>
-            <a:ext cx="11277295" cy="5285232"/>
+            <a:ext cx="11277295" cy="5440680"/>
           </a:xfrm>
           <a:prstGeom prst="roundRect">
             <a:avLst>
@@ -3255,7 +3255,7 @@
         <p:spPr>
           <a:xfrm>
             <a:off x="457200" y="1097280"/>
-            <a:ext cx="2743200" cy="5285232"/>
+            <a:ext cx="2743200" cy="5440680"/>
           </a:xfrm>
           <a:prstGeom prst="rect">
             <a:avLst/>
@@ -3298,7 +3298,7 @@
         </p:nvSpPr>
         <p:spPr>
           <a:xfrm>
-            <a:off x="658368" y="1371600"/>
+            <a:off x="658368" y="1353312"/>
             <a:ext cx="2340864" cy="201168"/>
           </a:xfrm>
           <a:prstGeom prst="rect">
@@ -3331,8 +3331,8 @@
         </p:nvSpPr>
         <p:spPr>
           <a:xfrm>
-            <a:off x="658368" y="1591056"/>
-            <a:ext cx="2340864" cy="868680"/>
+            <a:off x="658368" y="1572768"/>
+            <a:ext cx="2340864" cy="777240"/>
           </a:xfrm>
           <a:prstGeom prst="rect">
             <a:avLst/>
@@ -3380,7 +3380,7 @@
         </p:nvSpPr>
         <p:spPr>
           <a:xfrm>
-            <a:off x="658368" y="2551176"/>
+            <a:off x="658368" y="2441448"/>
             <a:ext cx="2340864" cy="201168"/>
           </a:xfrm>
           <a:prstGeom prst="rect">
@@ -3413,8 +3413,8 @@
         </p:nvSpPr>
         <p:spPr>
           <a:xfrm>
-            <a:off x="658368" y="2752344"/>
-            <a:ext cx="2340864" cy="256032"/>
+            <a:off x="658368" y="2624328"/>
+            <a:ext cx="2340864" cy="237744"/>
           </a:xfrm>
           <a:prstGeom prst="rect">
             <a:avLst/>
@@ -3446,7 +3446,7 @@
         </p:nvSpPr>
         <p:spPr>
           <a:xfrm>
-            <a:off x="658368" y="3008376"/>
+            <a:off x="658368" y="2862072"/>
             <a:ext cx="2340864" cy="457200"/>
           </a:xfrm>
           <a:prstGeom prst="rect">
@@ -3495,7 +3495,7 @@
         </p:nvSpPr>
         <p:spPr>
           <a:xfrm>
-            <a:off x="658368" y="3511296"/>
+            <a:off x="658368" y="3246120"/>
             <a:ext cx="2340864" cy="201168"/>
           </a:xfrm>
           <a:prstGeom prst="rect">
@@ -3528,8 +3528,8 @@
         </p:nvSpPr>
         <p:spPr>
           <a:xfrm>
-            <a:off x="658368" y="3712464"/>
-            <a:ext cx="2340864" cy="1280160"/>
+            <a:off x="658368" y="3429000"/>
+            <a:ext cx="2340864" cy="1005840"/>
           </a:xfrm>
           <a:prstGeom prst="rect">
             <a:avLst/>
@@ -3561,8 +3561,8 @@
         </p:nvSpPr>
         <p:spPr>
           <a:xfrm>
-            <a:off x="658368" y="5038344"/>
-            <a:ext cx="2340864" cy="777240"/>
+            <a:off x="658368" y="5568696"/>
+            <a:ext cx="2340864" cy="749808"/>
           </a:xfrm>
           <a:prstGeom prst="roundRect">
             <a:avLst>
@@ -3609,7 +3609,7 @@
         </p:nvSpPr>
         <p:spPr>
           <a:xfrm>
-            <a:off x="658368" y="5111496"/>
+            <a:off x="658368" y="5641848"/>
             <a:ext cx="2340864" cy="164592"/>
           </a:xfrm>
           <a:prstGeom prst="rect">
@@ -3642,8 +3642,8 @@
         </p:nvSpPr>
         <p:spPr>
           <a:xfrm>
-            <a:off x="658368" y="5276088"/>
-            <a:ext cx="2340864" cy="530352"/>
+            <a:off x="658368" y="5806440"/>
+            <a:ext cx="2340864" cy="512064"/>
           </a:xfrm>
           <a:prstGeom prst="rect">
             <a:avLst/>
@@ -3692,7 +3692,7 @@
         <p:spPr>
           <a:xfrm>
             <a:off x="3200400" y="1097280"/>
-            <a:ext cx="8534095" cy="5285232"/>
+            <a:ext cx="8534095" cy="5440680"/>
           </a:xfrm>
           <a:prstGeom prst="rect">
             <a:avLst/>
@@ -5620,7 +5620,7 @@
         <p:spPr>
           <a:xfrm>
             <a:off x="3429000" y="5413248"/>
-            <a:ext cx="8076895" cy="530352"/>
+            <a:ext cx="8076895" cy="713232"/>
           </a:xfrm>
           <a:prstGeom prst="roundRect">
             <a:avLst>
@@ -5778,7 +5778,7 @@
         <p:spPr>
           <a:xfrm>
             <a:off x="3429000" y="5833872"/>
-            <a:ext cx="8076895" cy="109728"/>
+            <a:ext cx="8076895" cy="292608"/>
           </a:xfrm>
           <a:prstGeom prst="rect">
             <a:avLst/>
@@ -5810,8 +5810,8 @@
         </p:nvSpPr>
         <p:spPr>
           <a:xfrm>
-            <a:off x="457200" y="6455664"/>
-            <a:ext cx="11277295" cy="274320"/>
+            <a:off x="457200" y="6629400"/>
+            <a:ext cx="11277295" cy="256032"/>
           </a:xfrm>
           <a:prstGeom prst="roundRect">
             <a:avLst>
@@ -5858,8 +5858,8 @@
         </p:nvSpPr>
         <p:spPr>
           <a:xfrm>
-            <a:off x="457200" y="6455664"/>
-            <a:ext cx="73152" cy="274320"/>
+            <a:off x="457200" y="6629400"/>
+            <a:ext cx="73152" cy="256032"/>
           </a:xfrm>
           <a:prstGeom prst="rect">
             <a:avLst/>
@@ -5902,8 +5902,8 @@
         </p:nvSpPr>
         <p:spPr>
           <a:xfrm>
-            <a:off x="640080" y="6455664"/>
-            <a:ext cx="10911535" cy="274320"/>
+            <a:off x="640080" y="6629400"/>
+            <a:ext cx="10911535" cy="256032"/>
           </a:xfrm>
           <a:prstGeom prst="rect">
             <a:avLst/>

</xml_diff>